<commit_message>
Align three-worker rollout and go-live proof
</commit_message>
<xml_diff>
--- a/portal/public/downloads/KAIRALI-AI-METHOD-ADVANCED-CLI-BONUS-v7-PUBLIC-KIT.pptx
+++ b/portal/public/downloads/KAIRALI-AI-METHOD-ADVANCED-CLI-BONUS-v7-PUBLIC-KIT.pptx
@@ -2,34 +2,34 @@
 <file path=ppt/presentation.xml><?xml version="1.0" encoding="utf-8"?>
 <p:presentation xmlns:p="http://schemas.openxmlformats.org/presentationml/2006/main">
   <p:sldMasterIdLst>
-    <p:sldMasterId xmlns:r="http://schemas.openxmlformats.org/officeDocument/2006/relationships" id="2147483648" r:id="R8027ca10b8c04c17"/>
+    <p:sldMasterId xmlns:r="http://schemas.openxmlformats.org/officeDocument/2006/relationships" id="2147483648" r:id="Racdb6854300247f8"/>
   </p:sldMasterIdLst>
   <p:notesMasterIdLst>
-    <p:notesMasterId xmlns:r="http://schemas.openxmlformats.org/officeDocument/2006/relationships" r:id="R08f852ad32ab4ac6"/>
+    <p:notesMasterId xmlns:r="http://schemas.openxmlformats.org/officeDocument/2006/relationships" r:id="Rd114d0bb40684d0c"/>
   </p:notesMasterIdLst>
   <p:sldIdLst>
-    <p:sldId xmlns:r="http://schemas.openxmlformats.org/officeDocument/2006/relationships" id="256" r:id="Rb751ef748130497f"/>
-    <p:sldId xmlns:r="http://schemas.openxmlformats.org/officeDocument/2006/relationships" id="257" r:id="R317819fd9ad74710"/>
-    <p:sldId xmlns:r="http://schemas.openxmlformats.org/officeDocument/2006/relationships" id="258" r:id="R06e2f4d74b81467a"/>
-    <p:sldId xmlns:r="http://schemas.openxmlformats.org/officeDocument/2006/relationships" id="259" r:id="Rb9437ce882ab4ad5"/>
-    <p:sldId xmlns:r="http://schemas.openxmlformats.org/officeDocument/2006/relationships" id="260" r:id="Raf32652415254c17"/>
-    <p:sldId xmlns:r="http://schemas.openxmlformats.org/officeDocument/2006/relationships" id="261" r:id="Rcab748b1f90042ea"/>
-    <p:sldId xmlns:r="http://schemas.openxmlformats.org/officeDocument/2006/relationships" id="262" r:id="R05be38ca73034c7d"/>
-    <p:sldId xmlns:r="http://schemas.openxmlformats.org/officeDocument/2006/relationships" id="263" r:id="R991d8ec4a5434ea7"/>
-    <p:sldId xmlns:r="http://schemas.openxmlformats.org/officeDocument/2006/relationships" id="264" r:id="R7e131a260be04575"/>
-    <p:sldId xmlns:r="http://schemas.openxmlformats.org/officeDocument/2006/relationships" id="265" r:id="R24bb1793ec2f4823"/>
-    <p:sldId xmlns:r="http://schemas.openxmlformats.org/officeDocument/2006/relationships" id="266" r:id="R599fd5f144f34f8a"/>
-    <p:sldId xmlns:r="http://schemas.openxmlformats.org/officeDocument/2006/relationships" id="267" r:id="Ra2b69ce7324047da"/>
-    <p:sldId xmlns:r="http://schemas.openxmlformats.org/officeDocument/2006/relationships" id="268" r:id="R430050edd7874473"/>
-    <p:sldId xmlns:r="http://schemas.openxmlformats.org/officeDocument/2006/relationships" id="269" r:id="R03da98ef0fce4cb3"/>
-    <p:sldId xmlns:r="http://schemas.openxmlformats.org/officeDocument/2006/relationships" id="270" r:id="R155caf9afe5a4567"/>
-    <p:sldId xmlns:r="http://schemas.openxmlformats.org/officeDocument/2006/relationships" id="271" r:id="Rf824fe68f7304fb2"/>
-    <p:sldId xmlns:r="http://schemas.openxmlformats.org/officeDocument/2006/relationships" id="272" r:id="R19a75c35842c4ab7"/>
-    <p:sldId xmlns:r="http://schemas.openxmlformats.org/officeDocument/2006/relationships" id="273" r:id="R7ff7063b5a504d95"/>
-    <p:sldId xmlns:r="http://schemas.openxmlformats.org/officeDocument/2006/relationships" id="274" r:id="R49b0069309424451"/>
-    <p:sldId xmlns:r="http://schemas.openxmlformats.org/officeDocument/2006/relationships" id="275" r:id="R96edce7ba64a47ac"/>
-    <p:sldId xmlns:r="http://schemas.openxmlformats.org/officeDocument/2006/relationships" id="276" r:id="R9e3b19682bc34bce"/>
-    <p:sldId xmlns:r="http://schemas.openxmlformats.org/officeDocument/2006/relationships" id="277" r:id="R982d59c15ab64e89"/>
+    <p:sldId xmlns:r="http://schemas.openxmlformats.org/officeDocument/2006/relationships" id="256" r:id="R133a7d034b95489e"/>
+    <p:sldId xmlns:r="http://schemas.openxmlformats.org/officeDocument/2006/relationships" id="257" r:id="Rd4e41235a5234506"/>
+    <p:sldId xmlns:r="http://schemas.openxmlformats.org/officeDocument/2006/relationships" id="258" r:id="Rdc4c053a4083481f"/>
+    <p:sldId xmlns:r="http://schemas.openxmlformats.org/officeDocument/2006/relationships" id="259" r:id="R51d83e939a5043bb"/>
+    <p:sldId xmlns:r="http://schemas.openxmlformats.org/officeDocument/2006/relationships" id="260" r:id="Raefa2570948542e5"/>
+    <p:sldId xmlns:r="http://schemas.openxmlformats.org/officeDocument/2006/relationships" id="261" r:id="Rad742536e6ae40c9"/>
+    <p:sldId xmlns:r="http://schemas.openxmlformats.org/officeDocument/2006/relationships" id="262" r:id="Rc091029d7a644f36"/>
+    <p:sldId xmlns:r="http://schemas.openxmlformats.org/officeDocument/2006/relationships" id="263" r:id="Re94a26095edb4784"/>
+    <p:sldId xmlns:r="http://schemas.openxmlformats.org/officeDocument/2006/relationships" id="264" r:id="Ra57a628bda344885"/>
+    <p:sldId xmlns:r="http://schemas.openxmlformats.org/officeDocument/2006/relationships" id="265" r:id="R520fbda361244c11"/>
+    <p:sldId xmlns:r="http://schemas.openxmlformats.org/officeDocument/2006/relationships" id="266" r:id="R35cbfd072fd04b8a"/>
+    <p:sldId xmlns:r="http://schemas.openxmlformats.org/officeDocument/2006/relationships" id="267" r:id="R75abb475fcff4f6c"/>
+    <p:sldId xmlns:r="http://schemas.openxmlformats.org/officeDocument/2006/relationships" id="268" r:id="R015ce8127ac044cd"/>
+    <p:sldId xmlns:r="http://schemas.openxmlformats.org/officeDocument/2006/relationships" id="269" r:id="Ra1c4e53f809b4f68"/>
+    <p:sldId xmlns:r="http://schemas.openxmlformats.org/officeDocument/2006/relationships" id="270" r:id="Rc4e474be28e2470a"/>
+    <p:sldId xmlns:r="http://schemas.openxmlformats.org/officeDocument/2006/relationships" id="271" r:id="R81f1e60166a149ae"/>
+    <p:sldId xmlns:r="http://schemas.openxmlformats.org/officeDocument/2006/relationships" id="272" r:id="R24772b7552434ee9"/>
+    <p:sldId xmlns:r="http://schemas.openxmlformats.org/officeDocument/2006/relationships" id="273" r:id="Rb5ba1cb84e2547b0"/>
+    <p:sldId xmlns:r="http://schemas.openxmlformats.org/officeDocument/2006/relationships" id="274" r:id="Rbebfbad865db4926"/>
+    <p:sldId xmlns:r="http://schemas.openxmlformats.org/officeDocument/2006/relationships" id="275" r:id="R9882ae64c49b4dff"/>
+    <p:sldId xmlns:r="http://schemas.openxmlformats.org/officeDocument/2006/relationships" id="276" r:id="Rdee8081c21644fab"/>
+    <p:sldId xmlns:r="http://schemas.openxmlformats.org/officeDocument/2006/relationships" id="277" r:id="Raa41492801e343c8"/>
   </p:sldIdLst>
   <p:sldSz cx="12192000" cy="6858000"/>
   <p:notesSz cx="6858000" cy="9144000"/>
@@ -2652,7 +2652,7 @@
           <a:lstStyle xmlns:a="http://schemas.openxmlformats.org/drawingml/2006/main"/>
           <a:p xmlns:a="http://schemas.openxmlformats.org/drawingml/2006/main">
             <a:r>
-              <a:t>Teach two homes. The public release provides governed system files, company kit, homework starters and optional skills. The work project is separate: a named private operations repository only when assigned, otherwise an approved local worker.</a:t>
+              <a:t>Teach two homes. The public release provides governed system files, company kit, homework starters and optional skills. The work project is separate: a named private operations repository only when assigned, otherwise an approved local worker. Availability in the public kit is not activation in an employee account. Daily Email and Full Drive need their named local proof; TEST 25 is Drive setup only. Saturday LinkedIn remains optional and may be recorded NOT ENABLED BY CHOICE.</a:t>
             </a:r>
             <a:endParaRPr/>
           </a:p>
@@ -2671,6 +2671,12 @@
           <a:p xmlns:a="http://schemas.openxmlformats.org/drawingml/2006/main">
             <a:r>
               <a:t>- https://github.com/kairali-digital/ai-human-workspace/releases/tag/v1.5.0</a:t>
+            </a:r>
+            <a:endParaRPr/>
+          </a:p>
+          <a:p xmlns:a="http://schemas.openxmlformats.org/drawingml/2006/main">
+            <a:r>
+              <a:t>- Kairali repository: packages/kairali/homework/THREE-WORKER-GO-LIVE-CHECKLIST.md</a:t>
             </a:r>
             <a:endParaRPr/>
           </a:p>
@@ -3305,7 +3311,7 @@
   </p:cSld>
   <p:clrMap bg1="lt1" tx1="dk1" bg2="lt2" tx2="dk2" accent1="accent1" accent2="accent2" accent3="accent3" accent4="accent4" accent5="accent5" accent6="accent6" hlink="hlink" folHlink="folHlink"/>
   <p:sldLayoutIdLst>
-    <p:sldLayoutId xmlns:r="http://schemas.openxmlformats.org/officeDocument/2006/relationships" id="2147483649" r:id="Ra71e9d26338042bb"/>
+    <p:sldLayoutId xmlns:r="http://schemas.openxmlformats.org/officeDocument/2006/relationships" id="2147483649" r:id="Rcb16f6b43fe848cd"/>
   </p:sldLayoutIdLst>
   <p:hf sldNum="0" hdr="0" ftr="0" dt="0"/>
   <p:txStyles>
@@ -4756,7 +4762,7 @@
           <p:nvPr/>
         </p:nvPicPr>
         <p:blipFill>
-          <a:blip xmlns:r="http://schemas.openxmlformats.org/officeDocument/2006/relationships" xmlns:a="http://schemas.openxmlformats.org/drawingml/2006/main" r:embed="Rea535458b2824f4d"/>
+          <a:blip xmlns:r="http://schemas.openxmlformats.org/officeDocument/2006/relationships" xmlns:a="http://schemas.openxmlformats.org/drawingml/2006/main" r:embed="R53c904ef4f404ef9"/>
           <a:stretch xmlns:a="http://schemas.openxmlformats.org/drawingml/2006/main">
             <a:fillRect l="0" t="0" r="0" b="0"/>
           </a:stretch>
@@ -6977,7 +6983,7 @@
           <p:nvPr/>
         </p:nvPicPr>
         <p:blipFill>
-          <a:blip xmlns:r="http://schemas.openxmlformats.org/officeDocument/2006/relationships" xmlns:a="http://schemas.openxmlformats.org/drawingml/2006/main" r:embed="R3a9628fe4b6b4ff4"/>
+          <a:blip xmlns:r="http://schemas.openxmlformats.org/officeDocument/2006/relationships" xmlns:a="http://schemas.openxmlformats.org/drawingml/2006/main" r:embed="Redb71abe62684cce"/>
           <a:stretch xmlns:a="http://schemas.openxmlformats.org/drawingml/2006/main">
             <a:fillRect l="0" t="0" r="0" b="0"/>
           </a:stretch>
@@ -7402,7 +7408,7 @@
           <p:nvPr/>
         </p:nvPicPr>
         <p:blipFill>
-          <a:blip xmlns:r="http://schemas.openxmlformats.org/officeDocument/2006/relationships" xmlns:a="http://schemas.openxmlformats.org/drawingml/2006/main" r:embed="R5b30d8021e724bb7"/>
+          <a:blip xmlns:r="http://schemas.openxmlformats.org/officeDocument/2006/relationships" xmlns:a="http://schemas.openxmlformats.org/drawingml/2006/main" r:embed="R3fcfb24975094546"/>
           <a:stretch xmlns:a="http://schemas.openxmlformats.org/drawingml/2006/main">
             <a:fillRect l="0" t="0" r="0" b="0"/>
           </a:stretch>
@@ -7580,7 +7586,7 @@
           <p:nvPr/>
         </p:nvPicPr>
         <p:blipFill>
-          <a:blip xmlns:r="http://schemas.openxmlformats.org/officeDocument/2006/relationships" xmlns:a="http://schemas.openxmlformats.org/drawingml/2006/main" r:embed="R096b29570d824333"/>
+          <a:blip xmlns:r="http://schemas.openxmlformats.org/officeDocument/2006/relationships" xmlns:a="http://schemas.openxmlformats.org/drawingml/2006/main" r:embed="R88a64b2c75cb4e42"/>
           <a:stretch xmlns:a="http://schemas.openxmlformats.org/drawingml/2006/main">
             <a:fillRect l="0" t="0" r="0" b="0"/>
           </a:stretch>
@@ -7758,7 +7764,7 @@
           <p:nvPr/>
         </p:nvPicPr>
         <p:blipFill>
-          <a:blip xmlns:r="http://schemas.openxmlformats.org/officeDocument/2006/relationships" xmlns:a="http://schemas.openxmlformats.org/drawingml/2006/main" r:embed="R45a1aee8cdfc42a8"/>
+          <a:blip xmlns:r="http://schemas.openxmlformats.org/officeDocument/2006/relationships" xmlns:a="http://schemas.openxmlformats.org/drawingml/2006/main" r:embed="R6ac425f8b3474edd"/>
           <a:stretch xmlns:a="http://schemas.openxmlformats.org/drawingml/2006/main">
             <a:fillRect l="0" t="0" r="0" b="0"/>
           </a:stretch>
@@ -12580,7 +12586,7 @@
           <p:nvPr/>
         </p:nvPicPr>
         <p:blipFill>
-          <a:blip xmlns:r="http://schemas.openxmlformats.org/officeDocument/2006/relationships" xmlns:a="http://schemas.openxmlformats.org/drawingml/2006/main" r:embed="Rfe2872591194412d"/>
+          <a:blip xmlns:r="http://schemas.openxmlformats.org/officeDocument/2006/relationships" xmlns:a="http://schemas.openxmlformats.org/drawingml/2006/main" r:embed="R53d883d3de45458b"/>
           <a:stretch xmlns:a="http://schemas.openxmlformats.org/drawingml/2006/main">
             <a:fillRect l="0" t="0" r="0" b="0"/>
           </a:stretch>
@@ -13000,7 +13006,7 @@
           <p:nvPr/>
         </p:nvPicPr>
         <p:blipFill>
-          <a:blip xmlns:r="http://schemas.openxmlformats.org/officeDocument/2006/relationships" xmlns:a="http://schemas.openxmlformats.org/drawingml/2006/main" r:embed="Rab3f3cff7bc04d43"/>
+          <a:blip xmlns:r="http://schemas.openxmlformats.org/officeDocument/2006/relationships" xmlns:a="http://schemas.openxmlformats.org/drawingml/2006/main" r:embed="Ra970233b342e4e8f"/>
           <a:stretch xmlns:a="http://schemas.openxmlformats.org/drawingml/2006/main">
             <a:fillRect l="0" t="0" r="0" b="0"/>
           </a:stretch>
@@ -13178,7 +13184,7 @@
           <p:nvPr/>
         </p:nvPicPr>
         <p:blipFill>
-          <a:blip xmlns:r="http://schemas.openxmlformats.org/officeDocument/2006/relationships" xmlns:a="http://schemas.openxmlformats.org/drawingml/2006/main" r:embed="R7e4d1eb669484ef2"/>
+          <a:blip xmlns:r="http://schemas.openxmlformats.org/officeDocument/2006/relationships" xmlns:a="http://schemas.openxmlformats.org/drawingml/2006/main" r:embed="Re945d98b461f44d5"/>
           <a:stretch xmlns:a="http://schemas.openxmlformats.org/drawingml/2006/main">
             <a:fillRect l="0" t="0" r="0" b="0"/>
           </a:stretch>
@@ -13356,7 +13362,7 @@
           <p:nvPr/>
         </p:nvPicPr>
         <p:blipFill>
-          <a:blip xmlns:r="http://schemas.openxmlformats.org/officeDocument/2006/relationships" xmlns:a="http://schemas.openxmlformats.org/drawingml/2006/main" r:embed="Rb185d522e3bc4ba0"/>
+          <a:blip xmlns:r="http://schemas.openxmlformats.org/officeDocument/2006/relationships" xmlns:a="http://schemas.openxmlformats.org/drawingml/2006/main" r:embed="R352433e0b88f49f9"/>
           <a:stretch xmlns:a="http://schemas.openxmlformats.org/drawingml/2006/main">
             <a:fillRect l="0" t="0" r="0" b="0"/>
           </a:stretch>
@@ -20498,7 +20504,7 @@
           <p:nvPr/>
         </p:nvPicPr>
         <p:blipFill>
-          <a:blip xmlns:r="http://schemas.openxmlformats.org/officeDocument/2006/relationships" xmlns:a="http://schemas.openxmlformats.org/drawingml/2006/main" r:embed="R11242d5a010a4069"/>
+          <a:blip xmlns:r="http://schemas.openxmlformats.org/officeDocument/2006/relationships" xmlns:a="http://schemas.openxmlformats.org/drawingml/2006/main" r:embed="R719d7dbab70c4d09"/>
           <a:stretch xmlns:a="http://schemas.openxmlformats.org/drawingml/2006/main">
             <a:fillRect l="0" t="0" r="0" b="0"/>
           </a:stretch>
@@ -21414,7 +21420,7 @@
           <p:nvPr/>
         </p:nvPicPr>
         <p:blipFill>
-          <a:blip xmlns:r="http://schemas.openxmlformats.org/officeDocument/2006/relationships" xmlns:a="http://schemas.openxmlformats.org/drawingml/2006/main" r:embed="R72936b21af874c0c"/>
+          <a:blip xmlns:r="http://schemas.openxmlformats.org/officeDocument/2006/relationships" xmlns:a="http://schemas.openxmlformats.org/drawingml/2006/main" r:embed="Rdd45ee6942754441"/>
           <a:stretch xmlns:a="http://schemas.openxmlformats.org/drawingml/2006/main">
             <a:fillRect l="0" t="0" r="0" b="0"/>
           </a:stretch>

</xml_diff>